<commit_message>
Added 3s countdown variables
</commit_message>
<xml_diff>
--- a/cogni.sst.task/StopSignalImages.pptx
+++ b/cogni.sst.task/StopSignalImages.pptx
@@ -5,7 +5,7 @@
     <p:sldMasterId id="2147483648" r:id="rId1"/>
   </p:sldMasterIdLst>
   <p:notesMasterIdLst>
-    <p:notesMasterId r:id="rId11"/>
+    <p:notesMasterId r:id="rId15"/>
   </p:notesMasterIdLst>
   <p:sldIdLst>
     <p:sldId id="256" r:id="rId2"/>
@@ -17,6 +17,10 @@
     <p:sldId id="265" r:id="rId8"/>
     <p:sldId id="263" r:id="rId9"/>
     <p:sldId id="264" r:id="rId10"/>
+    <p:sldId id="266" r:id="rId11"/>
+    <p:sldId id="267" r:id="rId12"/>
+    <p:sldId id="268" r:id="rId13"/>
+    <p:sldId id="269" r:id="rId14"/>
   </p:sldIdLst>
   <p:sldSz cx="12192000" cy="6858000"/>
   <p:notesSz cx="6858000" cy="9144000"/>
@@ -205,7 +209,7 @@
           <a:p>
             <a:fld id="{E8DDAAD8-0EC7-4314-8E6C-925B0027C652}" type="datetimeFigureOut">
               <a:rPr lang="en-DK" smtClean="0"/>
-              <a:t>08/11/2024</a:t>
+              <a:t>10/19/2026</a:t>
             </a:fld>
             <a:endParaRPr lang="en-DK"/>
           </a:p>
@@ -364,7 +368,7 @@
           <a:p>
             <a:fld id="{FFC4B7A3-226D-44E8-84CB-03CFFB6589DC}" type="slidenum">
               <a:rPr lang="en-DK" smtClean="0"/>
-              <a:t>‹#›</a:t>
+              <a:t>‹nr.›</a:t>
             </a:fld>
             <a:endParaRPr lang="en-DK"/>
           </a:p>
@@ -574,6 +578,90 @@
     <p:extLst>
       <p:ext uri="{BB962C8B-B14F-4D97-AF65-F5344CB8AC3E}">
         <p14:creationId xmlns:p14="http://schemas.microsoft.com/office/powerpoint/2010/main" val="4197133762"/>
+      </p:ext>
+    </p:extLst>
+  </p:cSld>
+  <p:clrMapOvr>
+    <a:masterClrMapping/>
+  </p:clrMapOvr>
+</p:notes>
+</file>
+
+<file path=ppt/notesSlides/notesSlide10.xml><?xml version="1.0" encoding="utf-8"?>
+<p:notes xmlns:a="http://schemas.openxmlformats.org/drawingml/2006/main" xmlns:r="http://schemas.openxmlformats.org/officeDocument/2006/relationships" xmlns:p="http://schemas.openxmlformats.org/presentationml/2006/main">
+  <p:cSld>
+    <p:spTree>
+      <p:nvGrpSpPr>
+        <p:cNvPr id="1" name=""/>
+        <p:cNvGrpSpPr/>
+        <p:nvPr/>
+      </p:nvGrpSpPr>
+      <p:grpSpPr>
+        <a:xfrm>
+          <a:off x="0" y="0"/>
+          <a:ext cx="0" cy="0"/>
+          <a:chOff x="0" y="0"/>
+          <a:chExt cx="0" cy="0"/>
+        </a:xfrm>
+      </p:grpSpPr>
+      <p:sp>
+        <p:nvSpPr>
+          <p:cNvPr id="2" name="Pladsholder til slidebillede 1"/>
+          <p:cNvSpPr>
+            <a:spLocks noGrp="1" noRot="1" noChangeAspect="1"/>
+          </p:cNvSpPr>
+          <p:nvPr>
+            <p:ph type="sldImg"/>
+          </p:nvPr>
+        </p:nvSpPr>
+        <p:spPr/>
+      </p:sp>
+      <p:sp>
+        <p:nvSpPr>
+          <p:cNvPr id="3" name="Pladsholder til noter 2"/>
+          <p:cNvSpPr>
+            <a:spLocks noGrp="1"/>
+          </p:cNvSpPr>
+          <p:nvPr>
+            <p:ph type="body" idx="1"/>
+          </p:nvPr>
+        </p:nvSpPr>
+        <p:spPr/>
+        <p:txBody>
+          <a:bodyPr/>
+          <a:lstStyle/>
+          <a:p>
+            <a:endParaRPr lang="da-DK" dirty="0"/>
+          </a:p>
+        </p:txBody>
+      </p:sp>
+      <p:sp>
+        <p:nvSpPr>
+          <p:cNvPr id="4" name="Pladsholder til slidenummer 3"/>
+          <p:cNvSpPr>
+            <a:spLocks noGrp="1"/>
+          </p:cNvSpPr>
+          <p:nvPr>
+            <p:ph type="sldNum" sz="quarter" idx="5"/>
+          </p:nvPr>
+        </p:nvSpPr>
+        <p:spPr/>
+        <p:txBody>
+          <a:bodyPr/>
+          <a:lstStyle/>
+          <a:p>
+            <a:fld id="{FFC4B7A3-226D-44E8-84CB-03CFFB6589DC}" type="slidenum">
+              <a:rPr lang="en-DK" smtClean="0"/>
+              <a:t>11</a:t>
+            </a:fld>
+            <a:endParaRPr lang="en-DK"/>
+          </a:p>
+        </p:txBody>
+      </p:sp>
+    </p:spTree>
+    <p:extLst>
+      <p:ext uri="{BB962C8B-B14F-4D97-AF65-F5344CB8AC3E}">
+        <p14:creationId xmlns:p14="http://schemas.microsoft.com/office/powerpoint/2010/main" val="236973544"/>
       </p:ext>
     </p:extLst>
   </p:cSld>
@@ -1926,13 +2014,13 @@
           <p:nvPr/>
         </p:nvPicPr>
         <p:blipFill>
-          <a:blip r:embed="rId3">
+          <a:blip>
             <a:extLst>
               <a:ext uri="{28A0092B-C50C-407E-A947-70E740481C1C}">
                 <a14:useLocalDpi xmlns:a14="http://schemas.microsoft.com/office/drawing/2010/main" val="0"/>
               </a:ext>
               <a:ext uri="{96DAC541-7B7A-43D3-8B79-37D633B846F1}">
-                <asvg:svgBlip xmlns:asvg="http://schemas.microsoft.com/office/drawing/2016/SVG/main" r:embed="rId4"/>
+                <asvg:svgBlip xmlns:asvg="http://schemas.microsoft.com/office/drawing/2016/SVG/main" r:embed="rId3"/>
               </a:ext>
             </a:extLst>
           </a:blip>
@@ -1954,6 +2042,278 @@
     <p:extLst>
       <p:ext uri="{BB962C8B-B14F-4D97-AF65-F5344CB8AC3E}">
         <p14:creationId xmlns:p14="http://schemas.microsoft.com/office/powerpoint/2010/main" val="2220615399"/>
+      </p:ext>
+    </p:extLst>
+  </p:cSld>
+  <p:clrMapOvr>
+    <a:masterClrMapping/>
+  </p:clrMapOvr>
+</p:sld>
+</file>
+
+<file path=ppt/slides/slide10.xml><?xml version="1.0" encoding="utf-8"?>
+<p:sld xmlns:a="http://schemas.openxmlformats.org/drawingml/2006/main" xmlns:r="http://schemas.openxmlformats.org/officeDocument/2006/relationships" xmlns:p="http://schemas.openxmlformats.org/presentationml/2006/main">
+  <p:cSld>
+    <p:bg>
+      <p:bgPr>
+        <a:solidFill>
+          <a:schemeClr val="bg1"/>
+        </a:solidFill>
+        <a:effectLst/>
+      </p:bgPr>
+    </p:bg>
+    <p:spTree>
+      <p:nvGrpSpPr>
+        <p:cNvPr id="1" name=""/>
+        <p:cNvGrpSpPr/>
+        <p:nvPr/>
+      </p:nvGrpSpPr>
+      <p:grpSpPr>
+        <a:xfrm>
+          <a:off x="0" y="0"/>
+          <a:ext cx="0" cy="0"/>
+          <a:chOff x="0" y="0"/>
+          <a:chExt cx="0" cy="0"/>
+        </a:xfrm>
+      </p:grpSpPr>
+      <p:sp>
+        <p:nvSpPr>
+          <p:cNvPr id="3" name="TextBox 1">
+            <a:extLst>
+              <a:ext uri="{FF2B5EF4-FFF2-40B4-BE49-F238E27FC236}">
+                <a16:creationId xmlns:a16="http://schemas.microsoft.com/office/drawing/2014/main" id="{5EB33BD3-3BCC-EB0A-5B3A-71FEF1371FE3}"/>
+              </a:ext>
+            </a:extLst>
+          </p:cNvPr>
+          <p:cNvSpPr txBox="1"/>
+          <p:nvPr/>
+        </p:nvSpPr>
+        <p:spPr>
+          <a:xfrm>
+            <a:off x="4116868" y="2228671"/>
+            <a:ext cx="3958263" cy="2400657"/>
+          </a:xfrm>
+          <a:prstGeom prst="rect">
+            <a:avLst/>
+          </a:prstGeom>
+          <a:noFill/>
+        </p:spPr>
+        <p:txBody>
+          <a:bodyPr wrap="none" rtlCol="0">
+            <a:spAutoFit/>
+          </a:bodyPr>
+          <a:lstStyle/>
+          <a:p>
+            <a:r>
+              <a:rPr lang="en-GB" sz="15000" dirty="0"/>
+              <a:t>REST</a:t>
+            </a:r>
+            <a:endParaRPr lang="en-DK" sz="15000" dirty="0"/>
+          </a:p>
+        </p:txBody>
+      </p:sp>
+    </p:spTree>
+    <p:extLst>
+      <p:ext uri="{BB962C8B-B14F-4D97-AF65-F5344CB8AC3E}">
+        <p14:creationId xmlns:p14="http://schemas.microsoft.com/office/powerpoint/2010/main" val="47124462"/>
+      </p:ext>
+    </p:extLst>
+  </p:cSld>
+  <p:clrMapOvr>
+    <a:masterClrMapping/>
+  </p:clrMapOvr>
+</p:sld>
+</file>
+
+<file path=ppt/slides/slide11.xml><?xml version="1.0" encoding="utf-8"?>
+<p:sld xmlns:a="http://schemas.openxmlformats.org/drawingml/2006/main" xmlns:r="http://schemas.openxmlformats.org/officeDocument/2006/relationships" xmlns:p="http://schemas.openxmlformats.org/presentationml/2006/main">
+  <p:cSld>
+    <p:spTree>
+      <p:nvGrpSpPr>
+        <p:cNvPr id="1" name=""/>
+        <p:cNvGrpSpPr/>
+        <p:nvPr/>
+      </p:nvGrpSpPr>
+      <p:grpSpPr>
+        <a:xfrm>
+          <a:off x="0" y="0"/>
+          <a:ext cx="0" cy="0"/>
+          <a:chOff x="0" y="0"/>
+          <a:chExt cx="0" cy="0"/>
+        </a:xfrm>
+      </p:grpSpPr>
+      <p:sp>
+        <p:nvSpPr>
+          <p:cNvPr id="3" name="TextBox 1">
+            <a:extLst>
+              <a:ext uri="{FF2B5EF4-FFF2-40B4-BE49-F238E27FC236}">
+                <a16:creationId xmlns:a16="http://schemas.microsoft.com/office/drawing/2014/main" id="{66BA9A9F-5EC2-07D8-E6CD-F01B1ECABC24}"/>
+              </a:ext>
+            </a:extLst>
+          </p:cNvPr>
+          <p:cNvSpPr txBox="1"/>
+          <p:nvPr/>
+        </p:nvSpPr>
+        <p:spPr>
+          <a:xfrm>
+            <a:off x="5516354" y="2228671"/>
+            <a:ext cx="1159292" cy="2400657"/>
+          </a:xfrm>
+          <a:prstGeom prst="rect">
+            <a:avLst/>
+          </a:prstGeom>
+          <a:noFill/>
+        </p:spPr>
+        <p:txBody>
+          <a:bodyPr wrap="none" rtlCol="0">
+            <a:spAutoFit/>
+          </a:bodyPr>
+          <a:lstStyle/>
+          <a:p>
+            <a:r>
+              <a:rPr lang="en-GB" sz="15000" dirty="0"/>
+              <a:t>3</a:t>
+            </a:r>
+            <a:endParaRPr lang="en-DK" sz="15000" dirty="0"/>
+          </a:p>
+        </p:txBody>
+      </p:sp>
+    </p:spTree>
+    <p:extLst>
+      <p:ext uri="{BB962C8B-B14F-4D97-AF65-F5344CB8AC3E}">
+        <p14:creationId xmlns:p14="http://schemas.microsoft.com/office/powerpoint/2010/main" val="2438443069"/>
+      </p:ext>
+    </p:extLst>
+  </p:cSld>
+  <p:clrMapOvr>
+    <a:masterClrMapping/>
+  </p:clrMapOvr>
+</p:sld>
+</file>
+
+<file path=ppt/slides/slide12.xml><?xml version="1.0" encoding="utf-8"?>
+<p:sld xmlns:a="http://schemas.openxmlformats.org/drawingml/2006/main" xmlns:r="http://schemas.openxmlformats.org/officeDocument/2006/relationships" xmlns:p="http://schemas.openxmlformats.org/presentationml/2006/main">
+  <p:cSld>
+    <p:spTree>
+      <p:nvGrpSpPr>
+        <p:cNvPr id="1" name=""/>
+        <p:cNvGrpSpPr/>
+        <p:nvPr/>
+      </p:nvGrpSpPr>
+      <p:grpSpPr>
+        <a:xfrm>
+          <a:off x="0" y="0"/>
+          <a:ext cx="0" cy="0"/>
+          <a:chOff x="0" y="0"/>
+          <a:chExt cx="0" cy="0"/>
+        </a:xfrm>
+      </p:grpSpPr>
+      <p:sp>
+        <p:nvSpPr>
+          <p:cNvPr id="3" name="TextBox 1">
+            <a:extLst>
+              <a:ext uri="{FF2B5EF4-FFF2-40B4-BE49-F238E27FC236}">
+                <a16:creationId xmlns:a16="http://schemas.microsoft.com/office/drawing/2014/main" id="{20A0D62F-0674-815F-0845-D2166BDF8587}"/>
+              </a:ext>
+            </a:extLst>
+          </p:cNvPr>
+          <p:cNvSpPr txBox="1"/>
+          <p:nvPr/>
+        </p:nvSpPr>
+        <p:spPr>
+          <a:xfrm>
+            <a:off x="5516354" y="2228671"/>
+            <a:ext cx="1159292" cy="2400657"/>
+          </a:xfrm>
+          <a:prstGeom prst="rect">
+            <a:avLst/>
+          </a:prstGeom>
+          <a:noFill/>
+        </p:spPr>
+        <p:txBody>
+          <a:bodyPr wrap="none" rtlCol="0">
+            <a:spAutoFit/>
+          </a:bodyPr>
+          <a:lstStyle/>
+          <a:p>
+            <a:r>
+              <a:rPr lang="en-GB" sz="15000" dirty="0"/>
+              <a:t>2</a:t>
+            </a:r>
+            <a:endParaRPr lang="en-DK" sz="15000" dirty="0"/>
+          </a:p>
+        </p:txBody>
+      </p:sp>
+    </p:spTree>
+    <p:extLst>
+      <p:ext uri="{BB962C8B-B14F-4D97-AF65-F5344CB8AC3E}">
+        <p14:creationId xmlns:p14="http://schemas.microsoft.com/office/powerpoint/2010/main" val="1997779484"/>
+      </p:ext>
+    </p:extLst>
+  </p:cSld>
+  <p:clrMapOvr>
+    <a:masterClrMapping/>
+  </p:clrMapOvr>
+</p:sld>
+</file>
+
+<file path=ppt/slides/slide13.xml><?xml version="1.0" encoding="utf-8"?>
+<p:sld xmlns:a="http://schemas.openxmlformats.org/drawingml/2006/main" xmlns:r="http://schemas.openxmlformats.org/officeDocument/2006/relationships" xmlns:p="http://schemas.openxmlformats.org/presentationml/2006/main">
+  <p:cSld>
+    <p:spTree>
+      <p:nvGrpSpPr>
+        <p:cNvPr id="1" name=""/>
+        <p:cNvGrpSpPr/>
+        <p:nvPr/>
+      </p:nvGrpSpPr>
+      <p:grpSpPr>
+        <a:xfrm>
+          <a:off x="0" y="0"/>
+          <a:ext cx="0" cy="0"/>
+          <a:chOff x="0" y="0"/>
+          <a:chExt cx="0" cy="0"/>
+        </a:xfrm>
+      </p:grpSpPr>
+      <p:sp>
+        <p:nvSpPr>
+          <p:cNvPr id="3" name="TextBox 1">
+            <a:extLst>
+              <a:ext uri="{FF2B5EF4-FFF2-40B4-BE49-F238E27FC236}">
+                <a16:creationId xmlns:a16="http://schemas.microsoft.com/office/drawing/2014/main" id="{CB40964C-D632-0F69-C94B-78917F3193EE}"/>
+              </a:ext>
+            </a:extLst>
+          </p:cNvPr>
+          <p:cNvSpPr txBox="1"/>
+          <p:nvPr/>
+        </p:nvSpPr>
+        <p:spPr>
+          <a:xfrm>
+            <a:off x="5516354" y="2228671"/>
+            <a:ext cx="1159292" cy="2400657"/>
+          </a:xfrm>
+          <a:prstGeom prst="rect">
+            <a:avLst/>
+          </a:prstGeom>
+          <a:noFill/>
+        </p:spPr>
+        <p:txBody>
+          <a:bodyPr wrap="none" rtlCol="0">
+            <a:spAutoFit/>
+          </a:bodyPr>
+          <a:lstStyle/>
+          <a:p>
+            <a:r>
+              <a:rPr lang="en-GB" sz="15000" dirty="0"/>
+              <a:t>1</a:t>
+            </a:r>
+            <a:endParaRPr lang="en-DK" sz="15000" dirty="0"/>
+          </a:p>
+        </p:txBody>
+      </p:sp>
+    </p:spTree>
+    <p:extLst>
+      <p:ext uri="{BB962C8B-B14F-4D97-AF65-F5344CB8AC3E}">
+        <p14:creationId xmlns:p14="http://schemas.microsoft.com/office/powerpoint/2010/main" val="2144769190"/>
       </p:ext>
     </p:extLst>
   </p:cSld>
@@ -1995,13 +2355,13 @@
           <p:nvPr/>
         </p:nvPicPr>
         <p:blipFill>
-          <a:blip r:embed="rId3">
+          <a:blip>
             <a:extLst>
               <a:ext uri="{28A0092B-C50C-407E-A947-70E740481C1C}">
                 <a14:useLocalDpi xmlns:a14="http://schemas.microsoft.com/office/drawing/2010/main" val="0"/>
               </a:ext>
               <a:ext uri="{96DAC541-7B7A-43D3-8B79-37D633B846F1}">
-                <asvg:svgBlip xmlns:asvg="http://schemas.microsoft.com/office/drawing/2016/SVG/main" r:embed="rId4"/>
+                <asvg:svgBlip xmlns:asvg="http://schemas.microsoft.com/office/drawing/2016/SVG/main" r:embed="rId3"/>
               </a:ext>
             </a:extLst>
           </a:blip>
@@ -2113,13 +2473,13 @@
           <p:nvPr/>
         </p:nvPicPr>
         <p:blipFill>
-          <a:blip r:embed="rId3">
+          <a:blip>
             <a:extLst>
               <a:ext uri="{28A0092B-C50C-407E-A947-70E740481C1C}">
                 <a14:useLocalDpi xmlns:a14="http://schemas.microsoft.com/office/drawing/2010/main" val="0"/>
               </a:ext>
               <a:ext uri="{96DAC541-7B7A-43D3-8B79-37D633B846F1}">
-                <asvg:svgBlip xmlns:asvg="http://schemas.microsoft.com/office/drawing/2016/SVG/main" r:embed="rId4"/>
+                <asvg:svgBlip xmlns:asvg="http://schemas.microsoft.com/office/drawing/2016/SVG/main" r:embed="rId3"/>
               </a:ext>
             </a:extLst>
           </a:blip>
@@ -2231,13 +2591,13 @@
           <p:nvPr/>
         </p:nvPicPr>
         <p:blipFill>
-          <a:blip r:embed="rId3">
+          <a:blip>
             <a:extLst>
               <a:ext uri="{28A0092B-C50C-407E-A947-70E740481C1C}">
                 <a14:useLocalDpi xmlns:a14="http://schemas.microsoft.com/office/drawing/2010/main" val="0"/>
               </a:ext>
               <a:ext uri="{96DAC541-7B7A-43D3-8B79-37D633B846F1}">
-                <asvg:svgBlip xmlns:asvg="http://schemas.microsoft.com/office/drawing/2016/SVG/main" r:embed="rId4"/>
+                <asvg:svgBlip xmlns:asvg="http://schemas.microsoft.com/office/drawing/2016/SVG/main" r:embed="rId3"/>
               </a:ext>
             </a:extLst>
           </a:blip>
@@ -2596,13 +2956,13 @@
           <p:nvPr/>
         </p:nvPicPr>
         <p:blipFill>
-          <a:blip r:embed="rId3">
+          <a:blip>
             <a:extLst>
               <a:ext uri="{28A0092B-C50C-407E-A947-70E740481C1C}">
                 <a14:useLocalDpi xmlns:a14="http://schemas.microsoft.com/office/drawing/2010/main" val="0"/>
               </a:ext>
               <a:ext uri="{96DAC541-7B7A-43D3-8B79-37D633B846F1}">
-                <asvg:svgBlip xmlns:asvg="http://schemas.microsoft.com/office/drawing/2016/SVG/main" r:embed="rId4"/>
+                <asvg:svgBlip xmlns:asvg="http://schemas.microsoft.com/office/drawing/2016/SVG/main" r:embed="rId3"/>
               </a:ext>
             </a:extLst>
           </a:blip>

</xml_diff>